<commit_message>
docs: new tagline — 'Revolutionize your innovation process'
Updated across all deliverables:
- README.md / README_CN.md: subtitle replaced
- FORGE_AI_Deck.pptx / FORGE_AI_Deck_CN.pptx: title slide
- FORGE_AI_25_EN.pptx / FORGE_AI_25_CN.pptx: title slide

Co-Authored-By: Claude <noreply@anthropic.com>
</commit_message>
<xml_diff>
--- a/ppt/FORGE_AI_25_CN.pptx
+++ b/ppt/FORGE_AI_25_CN.pptx
@@ -3030,6 +3030,10 @@
           </a:solidFill>
           <a:ln/>
         </p:spPr>
+        <p:txBody>
+          <a:bodyPr/>
+          <a:p/>
+        </p:txBody>
       </p:sp>
       <p:sp>
         <p:nvSpPr>
@@ -3095,6 +3099,10 @@
             <a:prstDash val="solid"/>
           </a:ln>
         </p:spPr>
+        <p:txBody>
+          <a:bodyPr/>
+          <a:p/>
+        </p:txBody>
       </p:sp>
       <p:sp>
         <p:nvSpPr>
@@ -3196,6 +3204,10 @@
             <a:prstDash val="solid"/>
           </a:ln>
         </p:spPr>
+        <p:txBody>
+          <a:bodyPr/>
+          <a:p/>
+        </p:txBody>
       </p:sp>
     </p:spTree>
   </p:cSld>

</xml_diff>